<commit_message>
Portfolio data : rapport hebdomadaire XHS recréé dans la page (KPI, graphique jour par jour, lecture, vérification, plan d'action), sans téléchargement ; decks FR et EN corrigés
Co-Authored-By: Claude Opus 5.5 <noreply@anthropic.com>
Claude-Session: https://claude.ai/code/session_019StBhWM8CAYGpxX8hszSXy
</commit_message>
<xml_diff>
--- a/assets/Engoo_Weekly Report_EN.pptx
+++ b/assets/Engoo_Weekly Report_EN.pptx
@@ -4656,7 +4656,7 @@
                   <a:srgbClr val="FBE3E5"/>
                 </a:solidFill>
               </a:rPr>
-              <a:t>Chinese New Year campaign drives the strongest week of the quarter</a:t>
+              <a:t>Chinese New Year campaign drives the strongest week since tracking began</a:t>
             </a:r>
           </a:p>
         </p:txBody>
@@ -5270,7 +5270,7 @@
                 <a:latin typeface="Poppins"/>
                 <a:cs typeface="Poppins"/>
               </a:rPr>
-              <a:t>Best week of the quarter</a:t>
+              <a:t>Best week since tracking began</a:t>
             </a:r>
           </a:p>
         </p:txBody>
@@ -5482,7 +5482,7 @@
                 <a:latin typeface="Poppins"/>
                 <a:cs typeface="Poppins"/>
               </a:rPr>
-              <a:t>Followers more than doubled</a:t>
+              <a:t>New followers more than doubled</a:t>
             </a:r>
           </a:p>
         </p:txBody>
@@ -5906,7 +5906,7 @@
                 <a:latin typeface="Poppins"/>
                 <a:cs typeface="Poppins"/>
               </a:rPr>
-              <a:t>Reach hit a quarterly high</a:t>
+              <a:t>Profile visits climbed</a:t>
             </a:r>
           </a:p>
         </p:txBody>
@@ -5948,7 +5948,7 @@
                 <a:latin typeface="Poppins"/>
                 <a:cs typeface="Poppins"/>
               </a:rPr>
-              <a:t>Top posts cleared 3,000+ views each</a:t>
+              <a:t>175 profile visits  ·  +36% WoW</a:t>
             </a:r>
           </a:p>
         </p:txBody>
@@ -8075,7 +8075,7 @@
                   <a:srgbClr val="FFFFFF"/>
                 </a:solidFill>
               </a:rPr>
-              <a:t>Top Content</a:t>
+              <a:t>Content Highlights</a:t>
             </a:r>
           </a:p>
         </p:txBody>
@@ -8328,7 +8328,7 @@
                   <a:srgbClr val="2B2D42"/>
                 </a:solidFill>
               </a:rPr>
-              <a:t>Fortune rankings + lucky colors · #1 for saves</a:t>
+              <a:t>Fortune rankings + lucky colors</a:t>
             </a:r>
           </a:p>
         </p:txBody>
@@ -8668,7 +8668,7 @@
                   <a:srgbClr val="2B2D42"/>
                 </a:solidFill>
               </a:rPr>
-              <a:t>Bilingual riddles · most-commented post</a:t>
+              <a:t>Bilingual riddles for the Lantern Festival</a:t>
             </a:r>
           </a:p>
         </p:txBody>
@@ -8729,10 +8729,10 @@
       </p:sp>
       <p:sp>
         <p:nvSpPr>
-          <p:cNvPr id="16" name="Rectangle : coins arrondis 15">
-            <a:extLst>
-              <a:ext uri="{FF2B5EF4-FFF2-40B4-BE49-F238E27FC236}">
-                <a16:creationId xmlns:a16="http://schemas.microsoft.com/office/drawing/2014/main" id="{D719B1D7-FA18-4D1F-95CD-00C4B727DE1D}"/>
+          <p:cNvPr id="19" name="Rectangle 18">
+            <a:extLst>
+              <a:ext uri="{FF2B5EF4-FFF2-40B4-BE49-F238E27FC236}">
+                <a16:creationId xmlns:a16="http://schemas.microsoft.com/office/drawing/2014/main" id="{D1AE3124-FAB4-4D03-9469-403C638DA1A3}"/>
               </a:ext>
             </a:extLst>
           </p:cNvPr>
@@ -8741,16 +8741,14 @@
         </p:nvSpPr>
         <p:spPr>
           <a:xfrm>
-            <a:off x="1582310" y="2064026"/>
-            <a:ext cx="1127760" cy="330200"/>
-          </a:xfrm>
-          <a:prstGeom prst="roundRect">
-            <a:avLst/>
-          </a:prstGeom>
-          <a:solidFill>
-            <a:srgbClr val="A50D24"/>
-          </a:solidFill>
-          <a:ln w="12700" cap="flat" cmpd="sng" algn="ctr">
+            <a:off x="8922249" y="1886226"/>
+            <a:ext cx="2489200" cy="3276600"/>
+          </a:xfrm>
+          <a:prstGeom prst="rect">
+            <a:avLst/>
+          </a:prstGeom>
+          <a:noFill/>
+          <a:ln w="38100" cap="flat" cmpd="sng" algn="ctr">
             <a:solidFill>
               <a:srgbClr val="F4C430"/>
             </a:solidFill>
@@ -8775,231 +8773,11 @@
           </a:fontRef>
         </p:style>
         <p:txBody>
-          <a:bodyPr vertOverflow="clip" horzOverflow="clip" wrap="none" rtlCol="0" anchor="ctr" anchorCtr="0">
-            <a:noAutofit/>
-          </a:bodyPr>
-          <a:lstStyle/>
-          <a:p>
-            <a:pPr algn="ctr"/>
-            <a:r>
-              <a:rPr lang="fr-FR" altLang="zh-TW" sz="1200" b="1" dirty="0">
-                <a:solidFill>
-                  <a:srgbClr val="FFE9A8"/>
-                </a:solidFill>
-                <a:latin typeface="Poppins"/>
-                <a:cs typeface="Poppins"/>
-              </a:rPr>
-              <a:t>TOP SAVES</a:t>
-            </a:r>
-            <a:endParaRPr lang="zh-TW" altLang="en-US" sz="1200" b="1" dirty="0">
-              <a:solidFill>
-                <a:srgbClr val="FFE9A8"/>
-              </a:solidFill>
-              <a:latin typeface="Poppins"/>
-              <a:cs typeface="Poppins"/>
-            </a:endParaRPr>
-          </a:p>
-        </p:txBody>
-      </p:sp>
-      <p:sp>
-        <p:nvSpPr>
-          <p:cNvPr id="19" name="Rectangle 18">
-            <a:extLst>
-              <a:ext uri="{FF2B5EF4-FFF2-40B4-BE49-F238E27FC236}">
-                <a16:creationId xmlns:a16="http://schemas.microsoft.com/office/drawing/2014/main" id="{D1AE3124-FAB4-4D03-9469-403C638DA1A3}"/>
-              </a:ext>
-            </a:extLst>
-          </p:cNvPr>
-          <p:cNvSpPr/>
-          <p:nvPr/>
-        </p:nvSpPr>
-        <p:spPr>
-          <a:xfrm>
-            <a:off x="8922249" y="1886226"/>
-            <a:ext cx="2489200" cy="3276600"/>
-          </a:xfrm>
-          <a:prstGeom prst="rect">
-            <a:avLst/>
-          </a:prstGeom>
-          <a:noFill/>
-          <a:ln w="38100" cap="flat" cmpd="sng" algn="ctr">
-            <a:solidFill>
-              <a:srgbClr val="F4C430"/>
-            </a:solidFill>
-            <a:prstDash val="solid"/>
-            <a:miter lim="800000"/>
-          </a:ln>
-        </p:spPr>
-        <p:style>
-          <a:lnRef idx="2">
-            <a:schemeClr val="accent1">
-              <a:shade val="15000"/>
-            </a:schemeClr>
-          </a:lnRef>
-          <a:fillRef idx="1">
-            <a:schemeClr val="accent1"/>
-          </a:fillRef>
-          <a:effectRef idx="0">
-            <a:schemeClr val="accent1"/>
-          </a:effectRef>
-          <a:fontRef idx="minor">
-            <a:schemeClr val="lt1"/>
-          </a:fontRef>
-        </p:style>
-        <p:txBody>
           <a:bodyPr vertOverflow="clip" horzOverflow="clip" rtlCol="0" anchor="t"/>
           <a:lstStyle/>
           <a:p>
             <a:pPr algn="l"/>
             <a:endParaRPr lang="zh-TW" altLang="en-US"/>
-          </a:p>
-        </p:txBody>
-      </p:sp>
-      <p:sp>
-        <p:nvSpPr>
-          <p:cNvPr id="18" name="Rectangle : coins arrondis 17">
-            <a:extLst>
-              <a:ext uri="{FF2B5EF4-FFF2-40B4-BE49-F238E27FC236}">
-                <a16:creationId xmlns:a16="http://schemas.microsoft.com/office/drawing/2014/main" id="{5CB36001-A052-4A38-85D8-123ADB6DEE20}"/>
-              </a:ext>
-            </a:extLst>
-          </p:cNvPr>
-          <p:cNvSpPr/>
-          <p:nvPr/>
-        </p:nvSpPr>
-        <p:spPr>
-          <a:xfrm>
-            <a:off x="5346148" y="2064026"/>
-            <a:ext cx="1310640" cy="330200"/>
-          </a:xfrm>
-          <a:prstGeom prst="roundRect">
-            <a:avLst/>
-          </a:prstGeom>
-          <a:solidFill>
-            <a:srgbClr val="A50D24"/>
-          </a:solidFill>
-          <a:ln w="12700" cap="flat" cmpd="sng" algn="ctr">
-            <a:solidFill>
-              <a:srgbClr val="F4C430"/>
-            </a:solidFill>
-            <a:prstDash val="solid"/>
-            <a:miter lim="800000"/>
-          </a:ln>
-        </p:spPr>
-        <p:style>
-          <a:lnRef idx="2">
-            <a:schemeClr val="accent1">
-              <a:shade val="15000"/>
-            </a:schemeClr>
-          </a:lnRef>
-          <a:fillRef idx="1">
-            <a:schemeClr val="accent1"/>
-          </a:fillRef>
-          <a:effectRef idx="0">
-            <a:schemeClr val="accent1"/>
-          </a:effectRef>
-          <a:fontRef idx="minor">
-            <a:schemeClr val="lt1"/>
-          </a:fontRef>
-        </p:style>
-        <p:txBody>
-          <a:bodyPr vertOverflow="clip" horzOverflow="clip" wrap="none" rtlCol="0" anchor="ctr" anchorCtr="0">
-            <a:noAutofit/>
-          </a:bodyPr>
-          <a:lstStyle/>
-          <a:p>
-            <a:pPr algn="ctr"/>
-            <a:r>
-              <a:rPr lang="fr-FR" altLang="zh-TW" sz="1200" b="1" dirty="0">
-                <a:solidFill>
-                  <a:srgbClr val="FFE9A8"/>
-                </a:solidFill>
-                <a:latin typeface="Poppins"/>
-                <a:cs typeface="Poppins"/>
-              </a:rPr>
-              <a:t>DAILY HABIT</a:t>
-            </a:r>
-            <a:endParaRPr lang="zh-TW" altLang="en-US" sz="1200" b="1" dirty="0">
-              <a:solidFill>
-                <a:srgbClr val="FFE9A8"/>
-              </a:solidFill>
-              <a:latin typeface="Poppins"/>
-              <a:cs typeface="Poppins"/>
-            </a:endParaRPr>
-          </a:p>
-        </p:txBody>
-      </p:sp>
-      <p:sp>
-        <p:nvSpPr>
-          <p:cNvPr id="20" name="Rectangle : coins arrondis 19">
-            <a:extLst>
-              <a:ext uri="{FF2B5EF4-FFF2-40B4-BE49-F238E27FC236}">
-                <a16:creationId xmlns:a16="http://schemas.microsoft.com/office/drawing/2014/main" id="{1D6299D5-375B-4EF6-88A9-A60A85428285}"/>
-              </a:ext>
-            </a:extLst>
-          </p:cNvPr>
-          <p:cNvSpPr/>
-          <p:nvPr/>
-        </p:nvSpPr>
-        <p:spPr>
-          <a:xfrm>
-            <a:off x="9420089" y="2064026"/>
-            <a:ext cx="1493520" cy="330200"/>
-          </a:xfrm>
-          <a:prstGeom prst="roundRect">
-            <a:avLst/>
-          </a:prstGeom>
-          <a:solidFill>
-            <a:srgbClr val="A50D24"/>
-          </a:solidFill>
-          <a:ln w="12700" cap="flat" cmpd="sng" algn="ctr">
-            <a:solidFill>
-              <a:srgbClr val="F4C430"/>
-            </a:solidFill>
-            <a:prstDash val="solid"/>
-            <a:miter lim="800000"/>
-          </a:ln>
-        </p:spPr>
-        <p:style>
-          <a:lnRef idx="2">
-            <a:schemeClr val="accent1">
-              <a:shade val="15000"/>
-            </a:schemeClr>
-          </a:lnRef>
-          <a:fillRef idx="1">
-            <a:schemeClr val="accent1"/>
-          </a:fillRef>
-          <a:effectRef idx="0">
-            <a:schemeClr val="accent1"/>
-          </a:effectRef>
-          <a:fontRef idx="minor">
-            <a:schemeClr val="lt1"/>
-          </a:fontRef>
-        </p:style>
-        <p:txBody>
-          <a:bodyPr vertOverflow="clip" horzOverflow="clip" wrap="none" rtlCol="0" anchor="ctr" anchorCtr="0">
-            <a:noAutofit/>
-          </a:bodyPr>
-          <a:lstStyle/>
-          <a:p>
-            <a:pPr algn="ctr"/>
-            <a:r>
-              <a:rPr lang="fr-FR" altLang="zh-TW" sz="1200" b="1" dirty="0">
-                <a:solidFill>
-                  <a:srgbClr val="FFE9A8"/>
-                </a:solidFill>
-                <a:latin typeface="Poppins"/>
-                <a:cs typeface="Poppins"/>
-              </a:rPr>
-              <a:t>MOST COMMENTS</a:t>
-            </a:r>
-            <a:endParaRPr lang="zh-TW" altLang="en-US" sz="1200" b="1" dirty="0">
-              <a:solidFill>
-                <a:srgbClr val="FFE9A8"/>
-              </a:solidFill>
-              <a:latin typeface="Poppins"/>
-              <a:cs typeface="Poppins"/>
-            </a:endParaRPr>
           </a:p>
         </p:txBody>
       </p:sp>
@@ -9327,7 +9105,7 @@
                   <a:srgbClr val="2B2D42"/>
                 </a:solidFill>
               </a:rPr>
-              <a:t>Posting Zodiac and Lantern content on the actual CNY dates put us in front of a surging, intent-driven audience.</a:t>
+              <a:t>Posting the Zodiac content on the actual CNY dates put us in front of a surging, intent-driven audience.</a:t>
             </a:r>
             <a:endParaRPr lang="zh-TW" altLang="en-US" sz="1400">
               <a:solidFill>
@@ -9871,7 +9649,7 @@
                   <a:srgbClr val="2B2D42"/>
                 </a:solidFill>
               </a:rPr>
-              <a:t>+47 followers (+147%) on flat ad spend — the holiday series converted browsers into subscribers.</a:t>
+              <a:t>+47 new followers (+147%): the holiday series converted browsers into subscribers.</a:t>
             </a:r>
             <a:endParaRPr lang="zh-TW" altLang="en-US" sz="1400">
               <a:solidFill>

</xml_diff>

<commit_message>
Rapport hebdomadaire XHS : nouvelles diapositives (exports PowerPoint) dans le carrousel marketing, couvertures refaites, anciens fichiers supprimés
Co-Authored-By: Claude Opus 5.5 <noreply@anthropic.com>
Claude-Session: https://claude.ai/code/session_019StBhWM8CAYGpxX8hszSXy
</commit_message>
<xml_diff>
--- a/assets/Engoo_Weekly Report_EN.pptx
+++ b/assets/Engoo_Weekly Report_EN.pptx
@@ -5,13 +5,13 @@
     <p:sldMasterId id="2147483672" r:id="rId1"/>
   </p:sldMasterIdLst>
   <p:sldIdLst>
-    <p:sldId id="284" r:id="rId2"/>
-    <p:sldId id="311" r:id="rId3"/>
+    <p:sldId id="314" r:id="rId2"/>
+    <p:sldId id="315" r:id="rId3"/>
     <p:sldId id="309" r:id="rId4"/>
-    <p:sldId id="312" r:id="rId5"/>
-    <p:sldId id="302" r:id="rId6"/>
+    <p:sldId id="316" r:id="rId5"/>
+    <p:sldId id="317" r:id="rId6"/>
     <p:sldId id="313" r:id="rId7"/>
-    <p:sldId id="300" r:id="rId8"/>
+    <p:sldId id="318" r:id="rId8"/>
   </p:sldIdLst>
   <p:sldSz cx="12192000" cy="6858000"/>
   <p:notesSz cx="6858000" cy="9144000"/>
@@ -1032,7 +1032,7 @@
           <a:p>
             <a:fld id="{FACCC3E1-D6CF-40B7-B817-18D62C8A9621}" type="datetimeFigureOut">
               <a:rPr lang="zh-TW" altLang="en-US" smtClean="0"/>
-              <a:t>2026/6/8</a:t>
+              <a:t>2026/10/23</a:t>
             </a:fld>
             <a:endParaRPr lang="zh-TW" altLang="en-US"/>
           </a:p>
@@ -1232,7 +1232,7 @@
           <a:p>
             <a:fld id="{FACCC3E1-D6CF-40B7-B817-18D62C8A9621}" type="datetimeFigureOut">
               <a:rPr lang="zh-TW" altLang="en-US" smtClean="0"/>
-              <a:t>2026/6/8</a:t>
+              <a:t>2026/10/23</a:t>
             </a:fld>
             <a:endParaRPr lang="zh-TW" altLang="en-US"/>
           </a:p>
@@ -1442,7 +1442,7 @@
           <a:p>
             <a:fld id="{FACCC3E1-D6CF-40B7-B817-18D62C8A9621}" type="datetimeFigureOut">
               <a:rPr lang="zh-TW" altLang="en-US" smtClean="0"/>
-              <a:t>2026/6/8</a:t>
+              <a:t>2026/10/23</a:t>
             </a:fld>
             <a:endParaRPr lang="zh-TW" altLang="en-US"/>
           </a:p>
@@ -1729,7 +1729,7 @@
           <a:p>
             <a:fld id="{FACCC3E1-D6CF-40B7-B817-18D62C8A9621}" type="datetimeFigureOut">
               <a:rPr lang="zh-TW" altLang="en-US" smtClean="0"/>
-              <a:t>2026/6/8</a:t>
+              <a:t>2026/10/23</a:t>
             </a:fld>
             <a:endParaRPr lang="zh-TW" altLang="en-US"/>
           </a:p>
@@ -2005,7 +2005,7 @@
           <a:p>
             <a:fld id="{FACCC3E1-D6CF-40B7-B817-18D62C8A9621}" type="datetimeFigureOut">
               <a:rPr lang="zh-TW" altLang="en-US" smtClean="0"/>
-              <a:t>2026/6/8</a:t>
+              <a:t>2026/10/23</a:t>
             </a:fld>
             <a:endParaRPr lang="zh-TW" altLang="en-US"/>
           </a:p>
@@ -2273,7 +2273,7 @@
           <a:p>
             <a:fld id="{FACCC3E1-D6CF-40B7-B817-18D62C8A9621}" type="datetimeFigureOut">
               <a:rPr lang="zh-TW" altLang="en-US" smtClean="0"/>
-              <a:t>2026/6/8</a:t>
+              <a:t>2026/10/23</a:t>
             </a:fld>
             <a:endParaRPr lang="zh-TW" altLang="en-US"/>
           </a:p>
@@ -2688,7 +2688,7 @@
           <a:p>
             <a:fld id="{FACCC3E1-D6CF-40B7-B817-18D62C8A9621}" type="datetimeFigureOut">
               <a:rPr lang="zh-TW" altLang="en-US" smtClean="0"/>
-              <a:t>2026/6/8</a:t>
+              <a:t>2026/10/23</a:t>
             </a:fld>
             <a:endParaRPr lang="zh-TW" altLang="en-US"/>
           </a:p>
@@ -2917,7 +2917,7 @@
           <a:p>
             <a:fld id="{FACCC3E1-D6CF-40B7-B817-18D62C8A9621}" type="datetimeFigureOut">
               <a:rPr lang="zh-TW" altLang="en-US" smtClean="0"/>
-              <a:t>2026/6/8</a:t>
+              <a:t>2026/10/23</a:t>
             </a:fld>
             <a:endParaRPr lang="zh-TW" altLang="en-US"/>
           </a:p>
@@ -3030,7 +3030,7 @@
           <a:p>
             <a:fld id="{FACCC3E1-D6CF-40B7-B817-18D62C8A9621}" type="datetimeFigureOut">
               <a:rPr lang="zh-TW" altLang="en-US" smtClean="0"/>
-              <a:t>2026/6/8</a:t>
+              <a:t>2026/10/23</a:t>
             </a:fld>
             <a:endParaRPr lang="zh-TW" altLang="en-US"/>
           </a:p>
@@ -3343,7 +3343,7 @@
           <a:p>
             <a:fld id="{FACCC3E1-D6CF-40B7-B817-18D62C8A9621}" type="datetimeFigureOut">
               <a:rPr lang="zh-TW" altLang="en-US" smtClean="0"/>
-              <a:t>2026/6/8</a:t>
+              <a:t>2026/10/23</a:t>
             </a:fld>
             <a:endParaRPr lang="zh-TW" altLang="en-US"/>
           </a:p>
@@ -3632,7 +3632,7 @@
           <a:p>
             <a:fld id="{FACCC3E1-D6CF-40B7-B817-18D62C8A9621}" type="datetimeFigureOut">
               <a:rPr lang="zh-TW" altLang="en-US" smtClean="0"/>
-              <a:t>2026/6/8</a:t>
+              <a:t>2026/10/23</a:t>
             </a:fld>
             <a:endParaRPr lang="zh-TW" altLang="en-US"/>
           </a:p>
@@ -3878,7 +3878,7 @@
           <a:p>
             <a:fld id="{FACCC3E1-D6CF-40B7-B817-18D62C8A9621}" type="datetimeFigureOut">
               <a:rPr lang="zh-TW" altLang="en-US" smtClean="0"/>
-              <a:t>2026/6/8</a:t>
+              <a:t>2026/10/23</a:t>
             </a:fld>
             <a:endParaRPr lang="zh-TW" altLang="en-US"/>
           </a:p>
@@ -4916,7 +4916,7 @@
         </p:blipFill>
         <p:spPr>
           <a:xfrm rot="2605941">
-            <a:off x="4106431" y="1076513"/>
+            <a:off x="4106431" y="1044709"/>
             <a:ext cx="3748038" cy="3748038"/>
           </a:xfrm>
           <a:custGeom>
@@ -5046,7 +5046,7 @@
     </p:spTree>
     <p:extLst>
       <p:ext uri="{BB962C8B-B14F-4D97-AF65-F5344CB8AC3E}">
-        <p14:creationId xmlns:p14="http://schemas.microsoft.com/office/powerpoint/2010/main" val="717031567"/>
+        <p14:creationId xmlns:p14="http://schemas.microsoft.com/office/powerpoint/2010/main" val="2034686778"/>
       </p:ext>
     </p:extLst>
   </p:cSld>
@@ -5119,8 +5119,8 @@
         </p:nvSpPr>
         <p:spPr>
           <a:xfrm>
-            <a:off x="736600" y="1879600"/>
-            <a:ext cx="10718800" cy="863600"/>
+            <a:off x="838200" y="1879600"/>
+            <a:ext cx="10515600" cy="863600"/>
           </a:xfrm>
           <a:prstGeom prst="roundRect">
             <a:avLst/>
@@ -5175,7 +5175,7 @@
         </p:nvSpPr>
         <p:spPr>
           <a:xfrm>
-            <a:off x="914400" y="2032000"/>
+            <a:off x="1041400" y="2032000"/>
             <a:ext cx="558800" cy="558800"/>
           </a:xfrm>
           <a:prstGeom prst="ellipse">
@@ -5247,8 +5247,8 @@
         </p:nvSpPr>
         <p:spPr>
           <a:xfrm>
-            <a:off x="1701800" y="1993900"/>
-            <a:ext cx="9550400" cy="338554"/>
+            <a:off x="1854200" y="1993900"/>
+            <a:ext cx="9296400" cy="338554"/>
           </a:xfrm>
           <a:prstGeom prst="rect">
             <a:avLst/>
@@ -5289,8 +5289,8 @@
         </p:nvSpPr>
         <p:spPr>
           <a:xfrm>
-            <a:off x="1701800" y="2298700"/>
-            <a:ext cx="9550400" cy="300082"/>
+            <a:off x="1854200" y="2298700"/>
+            <a:ext cx="9296400" cy="300082"/>
           </a:xfrm>
           <a:prstGeom prst="rect">
             <a:avLst/>
@@ -5305,7 +5305,7 @@
           <a:p>
             <a:pPr algn="l"/>
             <a:r>
-              <a:rPr lang="en-US" altLang="zh-TW" sz="1350" b="1" dirty="0">
+              <a:rPr lang="en-US" altLang="zh-TW" sz="1350" b="1">
                 <a:solidFill>
                   <a:srgbClr val="C8102E"/>
                 </a:solidFill>
@@ -5331,8 +5331,8 @@
         </p:nvSpPr>
         <p:spPr>
           <a:xfrm>
-            <a:off x="736600" y="2819400"/>
-            <a:ext cx="10718800" cy="863600"/>
+            <a:off x="838200" y="2819400"/>
+            <a:ext cx="10515600" cy="863600"/>
           </a:xfrm>
           <a:prstGeom prst="roundRect">
             <a:avLst/>
@@ -5387,7 +5387,7 @@
         </p:nvSpPr>
         <p:spPr>
           <a:xfrm>
-            <a:off x="914400" y="2971800"/>
+            <a:off x="1041400" y="2971800"/>
             <a:ext cx="558800" cy="558800"/>
           </a:xfrm>
           <a:prstGeom prst="ellipse">
@@ -5459,8 +5459,8 @@
         </p:nvSpPr>
         <p:spPr>
           <a:xfrm>
-            <a:off x="1701800" y="2933700"/>
-            <a:ext cx="9550400" cy="338554"/>
+            <a:off x="1854200" y="2933700"/>
+            <a:ext cx="9296400" cy="338554"/>
           </a:xfrm>
           <a:prstGeom prst="rect">
             <a:avLst/>
@@ -5501,8 +5501,8 @@
         </p:nvSpPr>
         <p:spPr>
           <a:xfrm>
-            <a:off x="1701800" y="3238500"/>
-            <a:ext cx="9550400" cy="300082"/>
+            <a:off x="1854200" y="3238500"/>
+            <a:ext cx="9296400" cy="300082"/>
           </a:xfrm>
           <a:prstGeom prst="rect">
             <a:avLst/>
@@ -5517,14 +5517,14 @@
           <a:p>
             <a:pPr algn="l"/>
             <a:r>
-              <a:rPr lang="en-US" altLang="zh-TW" sz="1350" b="1" dirty="0">
+              <a:rPr lang="en-US" altLang="zh-TW" sz="1350" b="1">
                 <a:solidFill>
                   <a:srgbClr val="C8102E"/>
                 </a:solidFill>
                 <a:latin typeface="Poppins"/>
                 <a:cs typeface="Poppins"/>
               </a:rPr>
-              <a:t>+47 new followers  ·  +147% WoW</a:t>
+              <a:t>+47 new  ·  +147% WoW</a:t>
             </a:r>
           </a:p>
         </p:txBody>
@@ -5543,8 +5543,8 @@
         </p:nvSpPr>
         <p:spPr>
           <a:xfrm>
-            <a:off x="736600" y="3759200"/>
-            <a:ext cx="10718800" cy="863600"/>
+            <a:off x="838200" y="3759200"/>
+            <a:ext cx="10515600" cy="863600"/>
           </a:xfrm>
           <a:prstGeom prst="roundRect">
             <a:avLst/>
@@ -5599,7 +5599,7 @@
         </p:nvSpPr>
         <p:spPr>
           <a:xfrm>
-            <a:off x="914400" y="3911600"/>
+            <a:off x="1041400" y="3911600"/>
             <a:ext cx="558800" cy="558800"/>
           </a:xfrm>
           <a:prstGeom prst="ellipse">
@@ -5671,8 +5671,8 @@
         </p:nvSpPr>
         <p:spPr>
           <a:xfrm>
-            <a:off x="1701800" y="3873500"/>
-            <a:ext cx="9550400" cy="338554"/>
+            <a:off x="1854200" y="3873500"/>
+            <a:ext cx="9296400" cy="338554"/>
           </a:xfrm>
           <a:prstGeom prst="rect">
             <a:avLst/>
@@ -5713,8 +5713,8 @@
         </p:nvSpPr>
         <p:spPr>
           <a:xfrm>
-            <a:off x="1701800" y="4178300"/>
-            <a:ext cx="9550400" cy="300082"/>
+            <a:off x="1854200" y="4178300"/>
+            <a:ext cx="9296400" cy="300082"/>
           </a:xfrm>
           <a:prstGeom prst="rect">
             <a:avLst/>
@@ -5729,7 +5729,7 @@
           <a:p>
             <a:pPr algn="l"/>
             <a:r>
-              <a:rPr lang="en-US" altLang="zh-TW" sz="1350" b="1" dirty="0">
+              <a:rPr lang="en-US" altLang="zh-TW" sz="1350" b="1">
                 <a:solidFill>
                   <a:srgbClr val="C8102E"/>
                 </a:solidFill>
@@ -5755,8 +5755,8 @@
         </p:nvSpPr>
         <p:spPr>
           <a:xfrm>
-            <a:off x="736600" y="4699000"/>
-            <a:ext cx="10718800" cy="863600"/>
+            <a:off x="838200" y="4699000"/>
+            <a:ext cx="10515600" cy="863600"/>
           </a:xfrm>
           <a:prstGeom prst="roundRect">
             <a:avLst/>
@@ -5811,7 +5811,7 @@
         </p:nvSpPr>
         <p:spPr>
           <a:xfrm>
-            <a:off x="914400" y="4851400"/>
+            <a:off x="1041400" y="4851400"/>
             <a:ext cx="558800" cy="558800"/>
           </a:xfrm>
           <a:prstGeom prst="ellipse">
@@ -5883,8 +5883,8 @@
         </p:nvSpPr>
         <p:spPr>
           <a:xfrm>
-            <a:off x="1701800" y="4813300"/>
-            <a:ext cx="9550400" cy="338554"/>
+            <a:off x="1854200" y="4813300"/>
+            <a:ext cx="9296400" cy="338554"/>
           </a:xfrm>
           <a:prstGeom prst="rect">
             <a:avLst/>
@@ -5925,8 +5925,8 @@
         </p:nvSpPr>
         <p:spPr>
           <a:xfrm>
-            <a:off x="1701800" y="5118100"/>
-            <a:ext cx="9550400" cy="300082"/>
+            <a:off x="1854200" y="5118100"/>
+            <a:ext cx="9296400" cy="300082"/>
           </a:xfrm>
           <a:prstGeom prst="rect">
             <a:avLst/>
@@ -5967,8 +5967,8 @@
         </p:nvSpPr>
         <p:spPr>
           <a:xfrm>
-            <a:off x="736600" y="5638800"/>
-            <a:ext cx="10718800" cy="863600"/>
+            <a:off x="838200" y="5638800"/>
+            <a:ext cx="10515600" cy="863600"/>
           </a:xfrm>
           <a:prstGeom prst="roundRect">
             <a:avLst/>
@@ -6023,7 +6023,7 @@
         </p:nvSpPr>
         <p:spPr>
           <a:xfrm>
-            <a:off x="914400" y="5791200"/>
+            <a:off x="1041400" y="5791200"/>
             <a:ext cx="558800" cy="558800"/>
           </a:xfrm>
           <a:prstGeom prst="ellipse">
@@ -6088,8 +6088,8 @@
         </p:nvSpPr>
         <p:spPr>
           <a:xfrm>
-            <a:off x="1701800" y="5753100"/>
-            <a:ext cx="9550400" cy="338554"/>
+            <a:off x="1854200" y="5753100"/>
+            <a:ext cx="9296400" cy="338554"/>
           </a:xfrm>
           <a:prstGeom prst="rect">
             <a:avLst/>
@@ -6130,8 +6130,8 @@
         </p:nvSpPr>
         <p:spPr>
           <a:xfrm>
-            <a:off x="1701800" y="6057900"/>
-            <a:ext cx="9550400" cy="300082"/>
+            <a:off x="1854200" y="6057900"/>
+            <a:ext cx="9296400" cy="300082"/>
           </a:xfrm>
           <a:prstGeom prst="rect">
             <a:avLst/>
@@ -6146,7 +6146,7 @@
           <a:p>
             <a:pPr algn="l"/>
             <a:r>
-              <a:rPr lang="en-US" altLang="zh-TW" sz="1350">
+              <a:rPr lang="en-US" altLang="zh-TW" sz="1350" dirty="0">
                 <a:solidFill>
                   <a:srgbClr val="3A3A44"/>
                 </a:solidFill>
@@ -6159,7 +6159,7 @@
     </p:spTree>
     <p:extLst>
       <p:ext uri="{BB962C8B-B14F-4D97-AF65-F5344CB8AC3E}">
-        <p14:creationId xmlns:p14="http://schemas.microsoft.com/office/powerpoint/2010/main" val="4030576522"/>
+        <p14:creationId xmlns:p14="http://schemas.microsoft.com/office/powerpoint/2010/main" val="3395444915"/>
       </p:ext>
     </p:extLst>
   </p:cSld>
@@ -6237,8 +6237,8 @@
         </p:nvSpPr>
         <p:spPr>
           <a:xfrm>
-            <a:off x="647700" y="1905000"/>
-            <a:ext cx="3429000" cy="1031460"/>
+            <a:off x="838200" y="1905000"/>
+            <a:ext cx="3302000" cy="1031240"/>
           </a:xfrm>
           <a:prstGeom prst="roundRect">
             <a:avLst/>
@@ -6293,8 +6293,8 @@
         </p:nvSpPr>
         <p:spPr>
           <a:xfrm>
-            <a:off x="876300" y="2026920"/>
-            <a:ext cx="2971800" cy="355600"/>
+            <a:off x="1066800" y="2026920"/>
+            <a:ext cx="2844800" cy="355600"/>
           </a:xfrm>
           <a:prstGeom prst="rect">
             <a:avLst/>
@@ -6343,8 +6343,8 @@
         </p:nvSpPr>
         <p:spPr>
           <a:xfrm>
-            <a:off x="876300" y="2311839"/>
-            <a:ext cx="2971800" cy="523220"/>
+            <a:off x="1066800" y="2311400"/>
+            <a:ext cx="2844800" cy="523220"/>
           </a:xfrm>
           <a:prstGeom prst="rect">
             <a:avLst/>
@@ -6392,7 +6392,7 @@
         </p:nvSpPr>
         <p:spPr>
           <a:xfrm>
-            <a:off x="2686050" y="2339341"/>
+            <a:off x="2736850" y="2339340"/>
             <a:ext cx="1219200" cy="381000"/>
           </a:xfrm>
           <a:prstGeom prst="roundRect">
@@ -6468,8 +6468,8 @@
         </p:nvSpPr>
         <p:spPr>
           <a:xfrm>
-            <a:off x="4381500" y="1905000"/>
-            <a:ext cx="3429000" cy="1031460"/>
+            <a:off x="4445000" y="1905000"/>
+            <a:ext cx="3302000" cy="1031240"/>
           </a:xfrm>
           <a:prstGeom prst="roundRect">
             <a:avLst/>
@@ -6524,8 +6524,8 @@
         </p:nvSpPr>
         <p:spPr>
           <a:xfrm>
-            <a:off x="4610100" y="2026920"/>
-            <a:ext cx="2971800" cy="355600"/>
+            <a:off x="4673600" y="2026920"/>
+            <a:ext cx="2844800" cy="355600"/>
           </a:xfrm>
           <a:prstGeom prst="rect">
             <a:avLst/>
@@ -6574,8 +6574,8 @@
         </p:nvSpPr>
         <p:spPr>
           <a:xfrm>
-            <a:off x="4610100" y="2311839"/>
-            <a:ext cx="2971800" cy="523220"/>
+            <a:off x="4673600" y="2311400"/>
+            <a:ext cx="2844800" cy="523220"/>
           </a:xfrm>
           <a:prstGeom prst="rect">
             <a:avLst/>
@@ -6623,7 +6623,7 @@
         </p:nvSpPr>
         <p:spPr>
           <a:xfrm>
-            <a:off x="6400800" y="2344420"/>
+            <a:off x="6343650" y="2339340"/>
             <a:ext cx="1219200" cy="381000"/>
           </a:xfrm>
           <a:prstGeom prst="roundRect">
@@ -6699,8 +6699,8 @@
         </p:nvSpPr>
         <p:spPr>
           <a:xfrm>
-            <a:off x="8115300" y="1905000"/>
-            <a:ext cx="3429000" cy="1031460"/>
+            <a:off x="8051800" y="1905000"/>
+            <a:ext cx="3302000" cy="1031240"/>
           </a:xfrm>
           <a:prstGeom prst="roundRect">
             <a:avLst/>
@@ -6755,8 +6755,8 @@
         </p:nvSpPr>
         <p:spPr>
           <a:xfrm>
-            <a:off x="8343900" y="2026920"/>
-            <a:ext cx="2971800" cy="355600"/>
+            <a:off x="8280400" y="2026920"/>
+            <a:ext cx="2844800" cy="355600"/>
           </a:xfrm>
           <a:prstGeom prst="rect">
             <a:avLst/>
@@ -6805,8 +6805,8 @@
         </p:nvSpPr>
         <p:spPr>
           <a:xfrm>
-            <a:off x="8343900" y="2311839"/>
-            <a:ext cx="2971800" cy="523220"/>
+            <a:off x="8280400" y="2311400"/>
+            <a:ext cx="2844800" cy="523220"/>
           </a:xfrm>
           <a:prstGeom prst="rect">
             <a:avLst/>
@@ -6854,7 +6854,7 @@
         </p:nvSpPr>
         <p:spPr>
           <a:xfrm>
-            <a:off x="10134600" y="2396545"/>
+            <a:off x="9950450" y="2339340"/>
             <a:ext cx="1219200" cy="381000"/>
           </a:xfrm>
           <a:prstGeom prst="roundRect">
@@ -6922,8 +6922,8 @@
         </p:nvSpPr>
         <p:spPr>
           <a:xfrm>
-            <a:off x="647700" y="3139439"/>
-            <a:ext cx="3429000" cy="1021919"/>
+            <a:off x="838200" y="3139440"/>
+            <a:ext cx="3302000" cy="1031240"/>
           </a:xfrm>
           <a:prstGeom prst="roundRect">
             <a:avLst/>
@@ -6978,8 +6978,8 @@
         </p:nvSpPr>
         <p:spPr>
           <a:xfrm>
-            <a:off x="876300" y="3261360"/>
-            <a:ext cx="2971800" cy="355600"/>
+            <a:off x="1066800" y="3261360"/>
+            <a:ext cx="2844800" cy="355600"/>
           </a:xfrm>
           <a:prstGeom prst="rect">
             <a:avLst/>
@@ -7028,8 +7028,8 @@
         </p:nvSpPr>
         <p:spPr>
           <a:xfrm>
-            <a:off x="876300" y="3546278"/>
-            <a:ext cx="2971800" cy="523220"/>
+            <a:off x="1066800" y="3545840"/>
+            <a:ext cx="2844800" cy="523220"/>
           </a:xfrm>
           <a:prstGeom prst="rect">
             <a:avLst/>
@@ -7077,7 +7077,7 @@
         </p:nvSpPr>
         <p:spPr>
           <a:xfrm>
-            <a:off x="2686050" y="3607020"/>
+            <a:off x="2736850" y="3573779"/>
             <a:ext cx="1219200" cy="381000"/>
           </a:xfrm>
           <a:prstGeom prst="roundRect">
@@ -7153,8 +7153,8 @@
         </p:nvSpPr>
         <p:spPr>
           <a:xfrm>
-            <a:off x="4381500" y="3139439"/>
-            <a:ext cx="3429000" cy="1021919"/>
+            <a:off x="4445000" y="3139440"/>
+            <a:ext cx="3302000" cy="1031240"/>
           </a:xfrm>
           <a:prstGeom prst="roundRect">
             <a:avLst/>
@@ -7209,8 +7209,8 @@
         </p:nvSpPr>
         <p:spPr>
           <a:xfrm>
-            <a:off x="4610100" y="3261360"/>
-            <a:ext cx="2971800" cy="355600"/>
+            <a:off x="4673600" y="3261360"/>
+            <a:ext cx="2844800" cy="355600"/>
           </a:xfrm>
           <a:prstGeom prst="rect">
             <a:avLst/>
@@ -7259,8 +7259,8 @@
         </p:nvSpPr>
         <p:spPr>
           <a:xfrm>
-            <a:off x="4610100" y="3546278"/>
-            <a:ext cx="2971800" cy="523220"/>
+            <a:off x="4673600" y="3545840"/>
+            <a:ext cx="2844800" cy="523220"/>
           </a:xfrm>
           <a:prstGeom prst="rect">
             <a:avLst/>
@@ -7308,7 +7308,7 @@
         </p:nvSpPr>
         <p:spPr>
           <a:xfrm>
-            <a:off x="6400800" y="3596639"/>
+            <a:off x="6343650" y="3573779"/>
             <a:ext cx="1219200" cy="381000"/>
           </a:xfrm>
           <a:prstGeom prst="roundRect">
@@ -7384,8 +7384,8 @@
         </p:nvSpPr>
         <p:spPr>
           <a:xfrm>
-            <a:off x="8115300" y="3139439"/>
-            <a:ext cx="3429000" cy="1021919"/>
+            <a:off x="8051800" y="3139440"/>
+            <a:ext cx="3302000" cy="1031240"/>
           </a:xfrm>
           <a:prstGeom prst="roundRect">
             <a:avLst/>
@@ -7440,8 +7440,8 @@
         </p:nvSpPr>
         <p:spPr>
           <a:xfrm>
-            <a:off x="8343900" y="3261360"/>
-            <a:ext cx="2971800" cy="355600"/>
+            <a:off x="8280400" y="3261360"/>
+            <a:ext cx="2844800" cy="355600"/>
           </a:xfrm>
           <a:prstGeom prst="rect">
             <a:avLst/>
@@ -7490,8 +7490,8 @@
         </p:nvSpPr>
         <p:spPr>
           <a:xfrm>
-            <a:off x="8343900" y="3546278"/>
-            <a:ext cx="2971800" cy="523220"/>
+            <a:off x="8280400" y="3545840"/>
+            <a:ext cx="2844800" cy="523220"/>
           </a:xfrm>
           <a:prstGeom prst="rect">
             <a:avLst/>
@@ -7549,7 +7549,7 @@
         </p:nvSpPr>
         <p:spPr>
           <a:xfrm>
-            <a:off x="10134600" y="3607020"/>
+            <a:off x="9950450" y="3573779"/>
             <a:ext cx="1219200" cy="381000"/>
           </a:xfrm>
           <a:prstGeom prst="roundRect">
@@ -7625,8 +7625,8 @@
         </p:nvSpPr>
         <p:spPr>
           <a:xfrm>
-            <a:off x="647700" y="6502400"/>
-            <a:ext cx="10896600" cy="304800"/>
+            <a:off x="838200" y="6502400"/>
+            <a:ext cx="10515600" cy="304800"/>
           </a:xfrm>
           <a:prstGeom prst="rect">
             <a:avLst/>
@@ -7686,8 +7686,8 @@
         </p:nvSpPr>
         <p:spPr>
           <a:xfrm>
-            <a:off x="647700" y="1905000"/>
-            <a:ext cx="3429000" cy="76200"/>
+            <a:off x="838200" y="1905000"/>
+            <a:ext cx="3302000" cy="76200"/>
           </a:xfrm>
           <a:prstGeom prst="rect">
             <a:avLst/>
@@ -7740,8 +7740,8 @@
         </p:nvSpPr>
         <p:spPr>
           <a:xfrm>
-            <a:off x="4381500" y="1905000"/>
-            <a:ext cx="3429000" cy="76200"/>
+            <a:off x="4445000" y="1905000"/>
+            <a:ext cx="3302000" cy="76200"/>
           </a:xfrm>
           <a:prstGeom prst="rect">
             <a:avLst/>
@@ -7794,8 +7794,8 @@
         </p:nvSpPr>
         <p:spPr>
           <a:xfrm>
-            <a:off x="8115300" y="1905000"/>
-            <a:ext cx="3429000" cy="76200"/>
+            <a:off x="8051800" y="1905000"/>
+            <a:ext cx="3302000" cy="76200"/>
           </a:xfrm>
           <a:prstGeom prst="rect">
             <a:avLst/>
@@ -7848,8 +7848,8 @@
         </p:nvSpPr>
         <p:spPr>
           <a:xfrm>
-            <a:off x="647700" y="3139439"/>
-            <a:ext cx="3429000" cy="76200"/>
+            <a:off x="838200" y="3139440"/>
+            <a:ext cx="3302000" cy="76200"/>
           </a:xfrm>
           <a:prstGeom prst="rect">
             <a:avLst/>
@@ -7902,8 +7902,8 @@
         </p:nvSpPr>
         <p:spPr>
           <a:xfrm>
-            <a:off x="4381500" y="3139439"/>
-            <a:ext cx="3429000" cy="76200"/>
+            <a:off x="4445000" y="3139440"/>
+            <a:ext cx="3302000" cy="76200"/>
           </a:xfrm>
           <a:prstGeom prst="rect">
             <a:avLst/>
@@ -7956,8 +7956,8 @@
         </p:nvSpPr>
         <p:spPr>
           <a:xfrm>
-            <a:off x="8115300" y="3139439"/>
-            <a:ext cx="3429000" cy="76200"/>
+            <a:off x="8051800" y="3139440"/>
+            <a:ext cx="3302000" cy="76200"/>
           </a:xfrm>
           <a:prstGeom prst="rect">
             <a:avLst/>
@@ -8003,14 +8003,14 @@
           <p:nvPr>
             <p:extLst>
               <p:ext uri="{D42A27DB-BD31-4B8C-83A1-F6EECF244321}">
-                <p14:modId xmlns:p14="http://schemas.microsoft.com/office/powerpoint/2010/main" val="3313983"/>
+                <p14:modId xmlns:p14="http://schemas.microsoft.com/office/powerpoint/2010/main" val="3654495304"/>
               </p:ext>
             </p:extLst>
           </p:nvPr>
         </p:nvGraphicFramePr>
         <p:xfrm>
-          <a:off x="762000" y="4222100"/>
-          <a:ext cx="10668000" cy="2371740"/>
+          <a:off x="838200" y="4241800"/>
+          <a:ext cx="10515600" cy="2235200"/>
         </p:xfrm>
         <a:graphic>
           <a:graphicData uri="http://schemas.openxmlformats.org/drawingml/2006/chart">
@@ -8102,7 +8102,7 @@
         </p:blipFill>
         <p:spPr>
           <a:xfrm>
-            <a:off x="952390" y="1937026"/>
+            <a:off x="889000" y="1937026"/>
             <a:ext cx="2387600" cy="3175000"/>
           </a:xfrm>
           <a:prstGeom prst="rect">
@@ -8132,7 +8132,7 @@
         </p:blipFill>
         <p:spPr>
           <a:xfrm>
-            <a:off x="4807668" y="1937026"/>
+            <a:off x="4902200" y="1937026"/>
             <a:ext cx="2387600" cy="3175000"/>
           </a:xfrm>
           <a:prstGeom prst="rect">
@@ -8162,7 +8162,7 @@
         </p:blipFill>
         <p:spPr>
           <a:xfrm>
-            <a:off x="8973049" y="1937026"/>
+            <a:off x="8915400" y="1937026"/>
             <a:ext cx="2387600" cy="3175000"/>
           </a:xfrm>
           <a:prstGeom prst="rect">
@@ -8184,7 +8184,7 @@
         </p:nvSpPr>
         <p:spPr>
           <a:xfrm>
-            <a:off x="952390" y="5213626"/>
+            <a:off x="889000" y="5213626"/>
             <a:ext cx="2387600" cy="50800"/>
           </a:xfrm>
           <a:prstGeom prst="rect">
@@ -8238,8 +8238,8 @@
         </p:nvSpPr>
         <p:spPr>
           <a:xfrm>
-            <a:off x="952389" y="5315226"/>
-            <a:ext cx="2999409" cy="338554"/>
+            <a:off x="889000" y="5314950"/>
+            <a:ext cx="2794000" cy="338554"/>
           </a:xfrm>
           <a:prstGeom prst="rect">
             <a:avLst/>
@@ -8307,8 +8307,8 @@
         </p:nvSpPr>
         <p:spPr>
           <a:xfrm>
-            <a:off x="952390" y="5692874"/>
-            <a:ext cx="2387600" cy="523220"/>
+            <a:off x="889000" y="5664200"/>
+            <a:ext cx="2794000" cy="307777"/>
           </a:xfrm>
           <a:prstGeom prst="rect">
             <a:avLst/>
@@ -8347,7 +8347,7 @@
         </p:nvSpPr>
         <p:spPr>
           <a:xfrm>
-            <a:off x="4807668" y="5213626"/>
+            <a:off x="4902200" y="5213626"/>
             <a:ext cx="2387600" cy="50800"/>
           </a:xfrm>
           <a:prstGeom prst="rect">
@@ -8401,8 +8401,8 @@
         </p:nvSpPr>
         <p:spPr>
           <a:xfrm>
-            <a:off x="4807668" y="5315226"/>
-            <a:ext cx="2387600" cy="660400"/>
+            <a:off x="4902200" y="5314950"/>
+            <a:ext cx="2794000" cy="660400"/>
           </a:xfrm>
           <a:prstGeom prst="rect">
             <a:avLst/>
@@ -8450,8 +8450,8 @@
         </p:nvSpPr>
         <p:spPr>
           <a:xfrm>
-            <a:off x="4807668" y="5692874"/>
-            <a:ext cx="2387600" cy="523220"/>
+            <a:off x="4902200" y="5664200"/>
+            <a:ext cx="2794000" cy="523220"/>
           </a:xfrm>
           <a:prstGeom prst="rect">
             <a:avLst/>
@@ -8490,7 +8490,7 @@
         </p:nvSpPr>
         <p:spPr>
           <a:xfrm>
-            <a:off x="8973049" y="5213626"/>
+            <a:off x="8915400" y="5213626"/>
             <a:ext cx="2387600" cy="50800"/>
           </a:xfrm>
           <a:prstGeom prst="rect">
@@ -8544,8 +8544,8 @@
         </p:nvSpPr>
         <p:spPr>
           <a:xfrm>
-            <a:off x="8973049" y="5315226"/>
-            <a:ext cx="2794882" cy="338554"/>
+            <a:off x="8915400" y="5314950"/>
+            <a:ext cx="2794000" cy="338554"/>
           </a:xfrm>
           <a:prstGeom prst="rect">
             <a:avLst/>
@@ -8593,7 +8593,7 @@
         </p:nvSpPr>
         <p:spPr>
           <a:xfrm>
-            <a:off x="901590" y="1886226"/>
+            <a:off x="838200" y="1886226"/>
             <a:ext cx="2489200" cy="3276600"/>
           </a:xfrm>
           <a:prstGeom prst="rect">
@@ -8647,8 +8647,8 @@
         </p:nvSpPr>
         <p:spPr>
           <a:xfrm>
-            <a:off x="8973049" y="5673217"/>
-            <a:ext cx="2387600" cy="523220"/>
+            <a:off x="8915400" y="5664200"/>
+            <a:ext cx="2794000" cy="523220"/>
           </a:xfrm>
           <a:prstGeom prst="rect">
             <a:avLst/>
@@ -8687,7 +8687,7 @@
         </p:nvSpPr>
         <p:spPr>
           <a:xfrm>
-            <a:off x="4756868" y="1886226"/>
+            <a:off x="4851400" y="1886226"/>
             <a:ext cx="2489200" cy="3276600"/>
           </a:xfrm>
           <a:prstGeom prst="rect">
@@ -8741,7 +8741,7 @@
         </p:nvSpPr>
         <p:spPr>
           <a:xfrm>
-            <a:off x="8922249" y="1886226"/>
+            <a:off x="8864600" y="1886226"/>
             <a:ext cx="2489200" cy="3276600"/>
           </a:xfrm>
           <a:prstGeom prst="rect">
@@ -8784,7 +8784,7 @@
     </p:spTree>
     <p:extLst>
       <p:ext uri="{BB962C8B-B14F-4D97-AF65-F5344CB8AC3E}">
-        <p14:creationId xmlns:p14="http://schemas.microsoft.com/office/powerpoint/2010/main" val="1327481644"/>
+        <p14:creationId xmlns:p14="http://schemas.microsoft.com/office/powerpoint/2010/main" val="365612779"/>
       </p:ext>
     </p:extLst>
   </p:cSld>
@@ -9934,7 +9934,7 @@
     </p:spTree>
     <p:extLst>
       <p:ext uri="{BB962C8B-B14F-4D97-AF65-F5344CB8AC3E}">
-        <p14:creationId xmlns:p14="http://schemas.microsoft.com/office/powerpoint/2010/main" val="2970656315"/>
+        <p14:creationId xmlns:p14="http://schemas.microsoft.com/office/powerpoint/2010/main" val="2527188824"/>
       </p:ext>
     </p:extLst>
   </p:cSld>
@@ -10007,8 +10007,8 @@
         </p:nvSpPr>
         <p:spPr>
           <a:xfrm>
-            <a:off x="736600" y="2032000"/>
-            <a:ext cx="10718800" cy="990600"/>
+            <a:off x="838200" y="2006600"/>
+            <a:ext cx="10515600" cy="990600"/>
           </a:xfrm>
           <a:prstGeom prst="roundRect">
             <a:avLst/>
@@ -10063,7 +10063,7 @@
         </p:nvSpPr>
         <p:spPr>
           <a:xfrm>
-            <a:off x="939800" y="2235200"/>
+            <a:off x="1041400" y="2209800"/>
             <a:ext cx="584200" cy="584200"/>
           </a:xfrm>
           <a:prstGeom prst="ellipse">
@@ -10135,8 +10135,8 @@
         </p:nvSpPr>
         <p:spPr>
           <a:xfrm>
-            <a:off x="1752600" y="2171700"/>
-            <a:ext cx="9474200" cy="304800"/>
+            <a:off x="1854200" y="2146300"/>
+            <a:ext cx="9296400" cy="304800"/>
           </a:xfrm>
           <a:prstGeom prst="rect">
             <a:avLst/>
@@ -10184,8 +10184,8 @@
         </p:nvSpPr>
         <p:spPr>
           <a:xfrm>
-            <a:off x="1752600" y="2501900"/>
-            <a:ext cx="9474200" cy="300082"/>
+            <a:off x="1854200" y="2476500"/>
+            <a:ext cx="9296400" cy="300082"/>
           </a:xfrm>
           <a:prstGeom prst="rect">
             <a:avLst/>
@@ -10224,8 +10224,8 @@
         </p:nvSpPr>
         <p:spPr>
           <a:xfrm>
-            <a:off x="736600" y="3149600"/>
-            <a:ext cx="10718800" cy="990600"/>
+            <a:off x="838200" y="3175000"/>
+            <a:ext cx="10515600" cy="990600"/>
           </a:xfrm>
           <a:prstGeom prst="roundRect">
             <a:avLst/>
@@ -10280,7 +10280,7 @@
         </p:nvSpPr>
         <p:spPr>
           <a:xfrm>
-            <a:off x="939800" y="3352800"/>
+            <a:off x="1041400" y="3378200"/>
             <a:ext cx="584200" cy="584200"/>
           </a:xfrm>
           <a:prstGeom prst="ellipse">
@@ -10352,8 +10352,8 @@
         </p:nvSpPr>
         <p:spPr>
           <a:xfrm>
-            <a:off x="1752600" y="3289300"/>
-            <a:ext cx="9474200" cy="304800"/>
+            <a:off x="1854200" y="3314700"/>
+            <a:ext cx="9296400" cy="304800"/>
           </a:xfrm>
           <a:prstGeom prst="rect">
             <a:avLst/>
@@ -10401,8 +10401,8 @@
         </p:nvSpPr>
         <p:spPr>
           <a:xfrm>
-            <a:off x="1752600" y="3619500"/>
-            <a:ext cx="9474200" cy="300082"/>
+            <a:off x="1854200" y="3644900"/>
+            <a:ext cx="9296400" cy="300082"/>
           </a:xfrm>
           <a:prstGeom prst="rect">
             <a:avLst/>
@@ -10441,8 +10441,8 @@
         </p:nvSpPr>
         <p:spPr>
           <a:xfrm>
-            <a:off x="736600" y="4267200"/>
-            <a:ext cx="10718800" cy="990600"/>
+            <a:off x="838200" y="4343400"/>
+            <a:ext cx="10515600" cy="990600"/>
           </a:xfrm>
           <a:prstGeom prst="roundRect">
             <a:avLst/>
@@ -10497,7 +10497,7 @@
         </p:nvSpPr>
         <p:spPr>
           <a:xfrm>
-            <a:off x="939800" y="4470400"/>
+            <a:off x="1041400" y="4546600"/>
             <a:ext cx="584200" cy="584200"/>
           </a:xfrm>
           <a:prstGeom prst="ellipse">
@@ -10569,8 +10569,8 @@
         </p:nvSpPr>
         <p:spPr>
           <a:xfrm>
-            <a:off x="1752600" y="4406900"/>
-            <a:ext cx="9474200" cy="304800"/>
+            <a:off x="1854200" y="4483100"/>
+            <a:ext cx="9296400" cy="304800"/>
           </a:xfrm>
           <a:prstGeom prst="rect">
             <a:avLst/>
@@ -10618,8 +10618,8 @@
         </p:nvSpPr>
         <p:spPr>
           <a:xfrm>
-            <a:off x="1752600" y="4737100"/>
-            <a:ext cx="9474200" cy="300082"/>
+            <a:off x="1854200" y="4813300"/>
+            <a:ext cx="9296400" cy="300082"/>
           </a:xfrm>
           <a:prstGeom prst="rect">
             <a:avLst/>
@@ -10658,8 +10658,8 @@
         </p:nvSpPr>
         <p:spPr>
           <a:xfrm>
-            <a:off x="736600" y="5384800"/>
-            <a:ext cx="10718800" cy="990600"/>
+            <a:off x="838200" y="5511800"/>
+            <a:ext cx="10515600" cy="990600"/>
           </a:xfrm>
           <a:prstGeom prst="roundRect">
             <a:avLst/>
@@ -10714,7 +10714,7 @@
         </p:nvSpPr>
         <p:spPr>
           <a:xfrm>
-            <a:off x="939800" y="5588000"/>
+            <a:off x="1041400" y="5715000"/>
             <a:ext cx="584200" cy="584200"/>
           </a:xfrm>
           <a:prstGeom prst="ellipse">
@@ -10786,8 +10786,8 @@
         </p:nvSpPr>
         <p:spPr>
           <a:xfrm>
-            <a:off x="1752600" y="5524500"/>
-            <a:ext cx="9474200" cy="304800"/>
+            <a:off x="1854200" y="5651500"/>
+            <a:ext cx="9296400" cy="304800"/>
           </a:xfrm>
           <a:prstGeom prst="rect">
             <a:avLst/>
@@ -10835,8 +10835,8 @@
         </p:nvSpPr>
         <p:spPr>
           <a:xfrm>
-            <a:off x="1752600" y="5854700"/>
-            <a:ext cx="9474200" cy="300082"/>
+            <a:off x="1854200" y="5981700"/>
+            <a:ext cx="9296400" cy="300082"/>
           </a:xfrm>
           <a:prstGeom prst="rect">
             <a:avLst/>
@@ -10938,8 +10938,8 @@
           <p:nvPr/>
         </p:nvGraphicFramePr>
         <p:xfrm>
-          <a:off x="762000" y="1905000"/>
-          <a:ext cx="10668000" cy="3479800"/>
+          <a:off x="838200" y="1905000"/>
+          <a:ext cx="10515598" cy="3479800"/>
         </p:xfrm>
         <a:graphic>
           <a:graphicData uri="http://schemas.openxmlformats.org/drawingml/2006/table">
@@ -10948,28 +10948,28 @@
                 <a:tableStyleId>{5C22544A-7EE6-4342-B048-85BDC9FD1C3A}</a:tableStyleId>
               </a:tblPr>
               <a:tblGrid>
-                <a:gridCol w="4064000">
+                <a:gridCol w="4005942">
                   <a:extLst>
                     <a:ext uri="{9D8B030D-6E8A-4147-A177-3AD203B41FA5}">
                       <a16:colId xmlns:a16="http://schemas.microsoft.com/office/drawing/2014/main" val="3648991615"/>
                     </a:ext>
                   </a:extLst>
                 </a:gridCol>
-                <a:gridCol w="1778000">
+                <a:gridCol w="1752600">
                   <a:extLst>
                     <a:ext uri="{9D8B030D-6E8A-4147-A177-3AD203B41FA5}">
                       <a16:colId xmlns:a16="http://schemas.microsoft.com/office/drawing/2014/main" val="1494634959"/>
                     </a:ext>
                   </a:extLst>
                 </a:gridCol>
-                <a:gridCol w="1524000">
+                <a:gridCol w="1502228">
                   <a:extLst>
                     <a:ext uri="{9D8B030D-6E8A-4147-A177-3AD203B41FA5}">
                       <a16:colId xmlns:a16="http://schemas.microsoft.com/office/drawing/2014/main" val="4041318134"/>
                     </a:ext>
                   </a:extLst>
                 </a:gridCol>
-                <a:gridCol w="3302000">
+                <a:gridCol w="3254828">
                   <a:extLst>
                     <a:ext uri="{9D8B030D-6E8A-4147-A177-3AD203B41FA5}">
                       <a16:colId xmlns:a16="http://schemas.microsoft.com/office/drawing/2014/main" val="4271670775"/>
@@ -10985,7 +10985,7 @@
                     <a:p>
                       <a:pPr algn="l"/>
                       <a:r>
-                        <a:rPr lang="zh-TW" altLang="en-US" sz="1500" b="1">
+                        <a:rPr lang="en-US" sz="1500" b="1">
                           <a:solidFill>
                             <a:srgbClr val="FFFFFF"/>
                           </a:solidFill>
@@ -11007,7 +11007,7 @@
                     <a:p>
                       <a:pPr algn="l"/>
                       <a:r>
-                        <a:rPr lang="zh-TW" altLang="en-US" sz="1500" b="1">
+                        <a:rPr lang="en-US" sz="1500" b="1">
                           <a:solidFill>
                             <a:srgbClr val="FFFFFF"/>
                           </a:solidFill>
@@ -11029,7 +11029,7 @@
                     <a:p>
                       <a:pPr algn="l"/>
                       <a:r>
-                        <a:rPr lang="zh-TW" altLang="en-US" sz="1500" b="1">
+                        <a:rPr lang="en-US" sz="1500" b="1">
                           <a:solidFill>
                             <a:srgbClr val="FFFFFF"/>
                           </a:solidFill>
@@ -11051,7 +11051,7 @@
                     <a:p>
                       <a:pPr algn="l"/>
                       <a:r>
-                        <a:rPr lang="zh-TW" altLang="en-US" sz="1500" b="1">
+                        <a:rPr lang="en-US" sz="1500" b="1">
                           <a:solidFill>
                             <a:srgbClr val="FFFFFF"/>
                           </a:solidFill>
@@ -11080,7 +11080,7 @@
                     <a:p>
                       <a:pPr algn="l"/>
                       <a:r>
-                        <a:rPr lang="zh-TW" altLang="en-US" sz="1400" b="1" dirty="0">
+                        <a:rPr lang="en-US" sz="1400" b="1" dirty="0">
                           <a:solidFill>
                             <a:srgbClr val="1A1A2E"/>
                           </a:solidFill>
@@ -11102,7 +11102,7 @@
                     <a:p>
                       <a:pPr algn="l"/>
                       <a:r>
-                        <a:rPr lang="zh-TW" altLang="en-US" sz="1400" b="1">
+                        <a:rPr lang="en-US" sz="1400" b="1">
                           <a:solidFill>
                             <a:srgbClr val="C8102E"/>
                           </a:solidFill>
@@ -11124,7 +11124,7 @@
                     <a:p>
                       <a:pPr algn="l"/>
                       <a:r>
-                        <a:rPr lang="zh-TW" altLang="en-US" sz="1400">
+                        <a:rPr lang="en-US" sz="1400">
                           <a:solidFill>
                             <a:srgbClr val="3A3A44"/>
                           </a:solidFill>
@@ -11146,7 +11146,7 @@
                     <a:p>
                       <a:pPr algn="l"/>
                       <a:r>
-                        <a:rPr lang="zh-TW" altLang="en-US" sz="1400">
+                        <a:rPr lang="en-US" sz="1400">
                           <a:solidFill>
                             <a:srgbClr val="3A3A44"/>
                           </a:solidFill>
@@ -11175,7 +11175,7 @@
                     <a:p>
                       <a:pPr algn="l"/>
                       <a:r>
-                        <a:rPr lang="zh-TW" altLang="en-US" sz="1400" b="1">
+                        <a:rPr lang="en-US" sz="1400" b="1">
                           <a:solidFill>
                             <a:srgbClr val="1A1A2E"/>
                           </a:solidFill>
@@ -11197,7 +11197,7 @@
                     <a:p>
                       <a:pPr algn="l"/>
                       <a:r>
-                        <a:rPr lang="zh-TW" altLang="en-US" sz="1400" b="1">
+                        <a:rPr lang="en-US" sz="1400" b="1">
                           <a:solidFill>
                             <a:srgbClr val="C8102E"/>
                           </a:solidFill>
@@ -11219,7 +11219,7 @@
                     <a:p>
                       <a:pPr algn="l"/>
                       <a:r>
-                        <a:rPr lang="zh-TW" altLang="en-US" sz="1400">
+                        <a:rPr lang="en-US" sz="1400">
                           <a:solidFill>
                             <a:srgbClr val="3A3A44"/>
                           </a:solidFill>
@@ -11241,7 +11241,7 @@
                     <a:p>
                       <a:pPr algn="l"/>
                       <a:r>
-                        <a:rPr lang="zh-TW" altLang="en-US" sz="1400">
+                        <a:rPr lang="en-US" sz="1400">
                           <a:solidFill>
                             <a:srgbClr val="3A3A44"/>
                           </a:solidFill>
@@ -11270,7 +11270,7 @@
                     <a:p>
                       <a:pPr algn="l"/>
                       <a:r>
-                        <a:rPr lang="zh-TW" altLang="en-US" sz="1400" b="1">
+                        <a:rPr lang="en-US" sz="1400" b="1">
                           <a:solidFill>
                             <a:srgbClr val="1A1A2E"/>
                           </a:solidFill>
@@ -11292,7 +11292,7 @@
                     <a:p>
                       <a:pPr algn="l"/>
                       <a:r>
-                        <a:rPr lang="zh-TW" altLang="en-US" sz="1400" b="1">
+                        <a:rPr lang="en-US" sz="1400" b="1">
                           <a:solidFill>
                             <a:srgbClr val="C8102E"/>
                           </a:solidFill>
@@ -11314,7 +11314,7 @@
                     <a:p>
                       <a:pPr algn="l"/>
                       <a:r>
-                        <a:rPr lang="zh-TW" altLang="en-US" sz="1400">
+                        <a:rPr lang="en-US" sz="1400">
                           <a:solidFill>
                             <a:srgbClr val="3A3A44"/>
                           </a:solidFill>
@@ -11336,7 +11336,7 @@
                     <a:p>
                       <a:pPr algn="l"/>
                       <a:r>
-                        <a:rPr lang="zh-TW" altLang="en-US" sz="1400">
+                        <a:rPr lang="en-US" sz="1400">
                           <a:solidFill>
                             <a:srgbClr val="3A3A44"/>
                           </a:solidFill>
@@ -11365,7 +11365,7 @@
                     <a:p>
                       <a:pPr algn="l"/>
                       <a:r>
-                        <a:rPr lang="zh-TW" altLang="en-US" sz="1400" b="1">
+                        <a:rPr lang="en-US" sz="1400" b="1">
                           <a:solidFill>
                             <a:srgbClr val="1A1A2E"/>
                           </a:solidFill>
@@ -11387,7 +11387,7 @@
                     <a:p>
                       <a:pPr algn="l"/>
                       <a:r>
-                        <a:rPr lang="zh-TW" altLang="en-US" sz="1400" b="1">
+                        <a:rPr lang="en-US" sz="1400" b="1">
                           <a:solidFill>
                             <a:srgbClr val="C8102E"/>
                           </a:solidFill>
@@ -11409,7 +11409,7 @@
                     <a:p>
                       <a:pPr algn="l"/>
                       <a:r>
-                        <a:rPr lang="zh-TW" altLang="en-US" sz="1400">
+                        <a:rPr lang="en-US" sz="1400">
                           <a:solidFill>
                             <a:srgbClr val="3A3A44"/>
                           </a:solidFill>
@@ -11431,7 +11431,7 @@
                     <a:p>
                       <a:pPr algn="l"/>
                       <a:r>
-                        <a:rPr lang="zh-TW" altLang="en-US" sz="1400">
+                        <a:rPr lang="en-US" sz="1400">
                           <a:solidFill>
                             <a:srgbClr val="3A3A44"/>
                           </a:solidFill>
@@ -11460,7 +11460,7 @@
                     <a:p>
                       <a:pPr algn="l"/>
                       <a:r>
-                        <a:rPr lang="zh-TW" altLang="en-US" sz="1400" b="1">
+                        <a:rPr lang="en-US" sz="1400" b="1">
                           <a:solidFill>
                             <a:srgbClr val="1A1A2E"/>
                           </a:solidFill>
@@ -11482,7 +11482,7 @@
                     <a:p>
                       <a:pPr algn="l"/>
                       <a:r>
-                        <a:rPr lang="zh-TW" altLang="en-US" sz="1400" b="1">
+                        <a:rPr lang="en-US" sz="1400" b="1">
                           <a:solidFill>
                             <a:srgbClr val="C8102E"/>
                           </a:solidFill>
@@ -11504,7 +11504,7 @@
                     <a:p>
                       <a:pPr algn="l"/>
                       <a:r>
-                        <a:rPr lang="zh-TW" altLang="en-US" sz="1400">
+                        <a:rPr lang="en-US" sz="1400">
                           <a:solidFill>
                             <a:srgbClr val="3A3A44"/>
                           </a:solidFill>
@@ -11526,7 +11526,7 @@
                     <a:p>
                       <a:pPr algn="l"/>
                       <a:r>
-                        <a:rPr lang="zh-TW" altLang="en-US" sz="1400" dirty="0">
+                        <a:rPr lang="en-US" sz="1400" dirty="0">
                           <a:solidFill>
                             <a:srgbClr val="3A3A44"/>
                           </a:solidFill>
@@ -11565,8 +11565,8 @@
         </p:nvSpPr>
         <p:spPr>
           <a:xfrm>
-            <a:off x="762000" y="5537200"/>
-            <a:ext cx="10668000" cy="50800"/>
+            <a:off x="838200" y="5537200"/>
+            <a:ext cx="10515600" cy="50800"/>
           </a:xfrm>
           <a:prstGeom prst="rect">
             <a:avLst/>
@@ -11601,7 +11601,7 @@
           <a:lstStyle/>
           <a:p>
             <a:pPr algn="l"/>
-            <a:endParaRPr lang="zh-TW" altLang="en-US"/>
+            <a:endParaRPr lang="en-US"/>
           </a:p>
         </p:txBody>
       </p:sp>
@@ -11619,8 +11619,8 @@
         </p:nvSpPr>
         <p:spPr>
           <a:xfrm>
-            <a:off x="762000" y="5664200"/>
-            <a:ext cx="10668000" cy="304800"/>
+            <a:off x="838200" y="5664200"/>
+            <a:ext cx="10515600" cy="304800"/>
           </a:xfrm>
           <a:prstGeom prst="rect">
             <a:avLst/>
@@ -11642,7 +11642,7 @@
               </a:rPr>
               <a:t>One owner per action · Review outcomes at next weekly sync</a:t>
             </a:r>
-            <a:endParaRPr lang="zh-TW" altLang="en-US" sz="1300" i="1">
+            <a:endParaRPr lang="en-US" sz="1300" i="1">
               <a:solidFill>
                 <a:srgbClr val="6B7280"/>
               </a:solidFill>
@@ -11653,7 +11653,7 @@
     </p:spTree>
     <p:extLst>
       <p:ext uri="{BB962C8B-B14F-4D97-AF65-F5344CB8AC3E}">
-        <p14:creationId xmlns:p14="http://schemas.microsoft.com/office/powerpoint/2010/main" val="3647413479"/>
+        <p14:creationId xmlns:p14="http://schemas.microsoft.com/office/powerpoint/2010/main" val="2632992392"/>
       </p:ext>
     </p:extLst>
   </p:cSld>
@@ -11980,7 +11980,7 @@
 
 <file path=ppt/webextensions/taskpanes.xml><?xml version="1.0" encoding="utf-8"?>
 <wetp:taskpanes xmlns:wetp="http://schemas.microsoft.com/office/webextensions/taskpanes/2010/11">
-  <wetp:taskpane dockstate="right" visibility="0" width="438" row="2">
+  <wetp:taskpane dockstate="right" visibility="0" width="438" row="0">
     <wetp:webextensionref xmlns:r="http://schemas.openxmlformats.org/officeDocument/2006/relationships" r:id="rId1"/>
   </wetp:taskpane>
 </wetp:taskpanes>

</xml_diff>